<commit_message>
docs: finalize presentation and public deployment review status
</commit_message>
<xml_diff>
--- a/AV2/CeTe-AV2-revision-tecnica.pptx
+++ b/AV2/CeTe-AV2-revision-tecnica.pptx
@@ -2,28 +2,28 @@
 <file path=ppt/presentation.xml><?xml version="1.0" encoding="utf-8"?>
 <p:presentation xmlns:p="http://schemas.openxmlformats.org/presentationml/2006/main">
   <p:sldMasterIdLst>
-    <p:sldMasterId xmlns:r="http://schemas.openxmlformats.org/officeDocument/2006/relationships" id="2147483648" r:id="R7bd29a6079fb43f6"/>
+    <p:sldMasterId xmlns:r="http://schemas.openxmlformats.org/officeDocument/2006/relationships" id="2147483648" r:id="R17aa430073694b13"/>
   </p:sldMasterIdLst>
   <p:notesMasterIdLst>
-    <p:notesMasterId xmlns:r="http://schemas.openxmlformats.org/officeDocument/2006/relationships" r:id="R11d70e73c8f64b7e"/>
+    <p:notesMasterId xmlns:r="http://schemas.openxmlformats.org/officeDocument/2006/relationships" r:id="R2e271c1e210946c7"/>
   </p:notesMasterIdLst>
   <p:sldIdLst>
-    <p:sldId xmlns:r="http://schemas.openxmlformats.org/officeDocument/2006/relationships" id="256" r:id="Re2e7548382b14cbd"/>
-    <p:sldId xmlns:r="http://schemas.openxmlformats.org/officeDocument/2006/relationships" id="257" r:id="Rc6e2a82d8ee2451e"/>
-    <p:sldId xmlns:r="http://schemas.openxmlformats.org/officeDocument/2006/relationships" id="258" r:id="R12a01182a8684bc2"/>
-    <p:sldId xmlns:r="http://schemas.openxmlformats.org/officeDocument/2006/relationships" id="259" r:id="R679712648f474af3"/>
-    <p:sldId xmlns:r="http://schemas.openxmlformats.org/officeDocument/2006/relationships" id="260" r:id="R29c66d61a89845c1"/>
-    <p:sldId xmlns:r="http://schemas.openxmlformats.org/officeDocument/2006/relationships" id="261" r:id="Re3520c87748e4a7e"/>
-    <p:sldId xmlns:r="http://schemas.openxmlformats.org/officeDocument/2006/relationships" id="262" r:id="Rd143e3ea7f924c63"/>
-    <p:sldId xmlns:r="http://schemas.openxmlformats.org/officeDocument/2006/relationships" id="263" r:id="Rbc6c8f1f1e294ca5"/>
-    <p:sldId xmlns:r="http://schemas.openxmlformats.org/officeDocument/2006/relationships" id="264" r:id="R02cb8942ad944f9d"/>
-    <p:sldId xmlns:r="http://schemas.openxmlformats.org/officeDocument/2006/relationships" id="265" r:id="R17358d715b294183"/>
-    <p:sldId xmlns:r="http://schemas.openxmlformats.org/officeDocument/2006/relationships" id="266" r:id="R4478da7d3aa948d1"/>
-    <p:sldId xmlns:r="http://schemas.openxmlformats.org/officeDocument/2006/relationships" id="267" r:id="R638bef33b2564d1f"/>
-    <p:sldId xmlns:r="http://schemas.openxmlformats.org/officeDocument/2006/relationships" id="268" r:id="R32cd3fdc228e4727"/>
-    <p:sldId xmlns:r="http://schemas.openxmlformats.org/officeDocument/2006/relationships" id="269" r:id="Re7eb0060bec34115"/>
-    <p:sldId xmlns:r="http://schemas.openxmlformats.org/officeDocument/2006/relationships" id="270" r:id="R5cbd6d0574ff45ea"/>
-    <p:sldId xmlns:r="http://schemas.openxmlformats.org/officeDocument/2006/relationships" id="271" r:id="Rd09645aa16904422"/>
+    <p:sldId xmlns:r="http://schemas.openxmlformats.org/officeDocument/2006/relationships" id="256" r:id="Rebf1f52b0b0a444d"/>
+    <p:sldId xmlns:r="http://schemas.openxmlformats.org/officeDocument/2006/relationships" id="257" r:id="R2d66735611c3494c"/>
+    <p:sldId xmlns:r="http://schemas.openxmlformats.org/officeDocument/2006/relationships" id="258" r:id="Rb7e5190df96c4dd4"/>
+    <p:sldId xmlns:r="http://schemas.openxmlformats.org/officeDocument/2006/relationships" id="259" r:id="R3792387b7f1c419e"/>
+    <p:sldId xmlns:r="http://schemas.openxmlformats.org/officeDocument/2006/relationships" id="260" r:id="R140e4e627da54ca5"/>
+    <p:sldId xmlns:r="http://schemas.openxmlformats.org/officeDocument/2006/relationships" id="261" r:id="Rc784da9a0bf64095"/>
+    <p:sldId xmlns:r="http://schemas.openxmlformats.org/officeDocument/2006/relationships" id="262" r:id="Rc41e67300cad4ff7"/>
+    <p:sldId xmlns:r="http://schemas.openxmlformats.org/officeDocument/2006/relationships" id="263" r:id="Reb3ced3a8bae4b4f"/>
+    <p:sldId xmlns:r="http://schemas.openxmlformats.org/officeDocument/2006/relationships" id="264" r:id="R652788eb5b5643ea"/>
+    <p:sldId xmlns:r="http://schemas.openxmlformats.org/officeDocument/2006/relationships" id="265" r:id="Rb7d13bbb85384096"/>
+    <p:sldId xmlns:r="http://schemas.openxmlformats.org/officeDocument/2006/relationships" id="266" r:id="Rad1203169e134239"/>
+    <p:sldId xmlns:r="http://schemas.openxmlformats.org/officeDocument/2006/relationships" id="267" r:id="R06a1d6ef5708412a"/>
+    <p:sldId xmlns:r="http://schemas.openxmlformats.org/officeDocument/2006/relationships" id="268" r:id="R84e90b28fac14510"/>
+    <p:sldId xmlns:r="http://schemas.openxmlformats.org/officeDocument/2006/relationships" id="269" r:id="R6640e958a3f44152"/>
+    <p:sldId xmlns:r="http://schemas.openxmlformats.org/officeDocument/2006/relationships" id="270" r:id="R61e49edcf1184277"/>
+    <p:sldId xmlns:r="http://schemas.openxmlformats.org/officeDocument/2006/relationships" id="271" r:id="R9568dfb87973424b"/>
   </p:sldIdLst>
   <p:sldSz cx="12192000" cy="6858000"/>
   <p:notesSz cx="6858000" cy="9144000"/>
@@ -1634,7 +1634,7 @@
           <p:cNvPr id="3" name="Title">
             <a:extLst xmlns:a="http://schemas.openxmlformats.org/drawingml/2006/main">
               <a:ext uri="{FF2B5EF4-FFF2-40B4-BE49-F238E27FC236}">
-                <a16:creationId xmlns:a16="http://schemas.microsoft.com/office/drawing/2014/main" id="{6D689168-91F1-4B44-BA0E-90AD35CC1816}"/>
+                <a16:creationId xmlns:a16="http://schemas.microsoft.com/office/drawing/2014/main" id="{809537E6-EDB1-426C-B925-3D5445151A1B}"/>
               </a:ext>
             </a:extLst>
           </p:cNvPr>
@@ -1863,7 +1863,7 @@
           <p:cNvPr id="2" name="Subtitle">
             <a:extLst xmlns:a="http://schemas.openxmlformats.org/drawingml/2006/main">
               <a:ext uri="{FF2B5EF4-FFF2-40B4-BE49-F238E27FC236}">
-                <a16:creationId xmlns:a16="http://schemas.microsoft.com/office/drawing/2014/main" id="{A8272A15-BE87-486F-BAC8-12D8B58A936B}"/>
+                <a16:creationId xmlns:a16="http://schemas.microsoft.com/office/drawing/2014/main" id="{AACB7924-E48D-478E-ADEC-E0A554D18609}"/>
               </a:ext>
             </a:extLst>
           </p:cNvPr>
@@ -2109,7 +2109,7 @@
           <p:cNvPr id="2" name="Section title">
             <a:extLst xmlns:a="http://schemas.openxmlformats.org/drawingml/2006/main">
               <a:ext uri="{FF2B5EF4-FFF2-40B4-BE49-F238E27FC236}">
-                <a16:creationId xmlns:a16="http://schemas.microsoft.com/office/drawing/2014/main" id="{8BD0DF77-21DE-43C1-818B-D8274C5DEDA3}"/>
+                <a16:creationId xmlns:a16="http://schemas.microsoft.com/office/drawing/2014/main" id="{290D8FB4-B96B-4CED-BA0D-0E15718C327D}"/>
               </a:ext>
             </a:extLst>
           </p:cNvPr>
@@ -2355,7 +2355,7 @@
           <p:cNvPr id="3" name="Title">
             <a:extLst xmlns:a="http://schemas.openxmlformats.org/drawingml/2006/main">
               <a:ext uri="{FF2B5EF4-FFF2-40B4-BE49-F238E27FC236}">
-                <a16:creationId xmlns:a16="http://schemas.microsoft.com/office/drawing/2014/main" id="{18522471-7C9D-4866-A322-BD3733B022D6}"/>
+                <a16:creationId xmlns:a16="http://schemas.microsoft.com/office/drawing/2014/main" id="{F1EFA53C-BCE9-4FDC-AEAB-1041777B6D78}"/>
               </a:ext>
             </a:extLst>
           </p:cNvPr>
@@ -2584,7 +2584,7 @@
           <p:cNvPr id="2" name="Body">
             <a:extLst xmlns:a="http://schemas.openxmlformats.org/drawingml/2006/main">
               <a:ext uri="{FF2B5EF4-FFF2-40B4-BE49-F238E27FC236}">
-                <a16:creationId xmlns:a16="http://schemas.microsoft.com/office/drawing/2014/main" id="{89C97DFE-AA35-4DAA-85D7-0052C49D60B2}"/>
+                <a16:creationId xmlns:a16="http://schemas.microsoft.com/office/drawing/2014/main" id="{F3072B5C-3874-4478-8820-DC680131C886}"/>
               </a:ext>
             </a:extLst>
           </p:cNvPr>
@@ -2830,7 +2830,7 @@
           <p:cNvPr id="4" name="Title">
             <a:extLst xmlns:a="http://schemas.openxmlformats.org/drawingml/2006/main">
               <a:ext uri="{FF2B5EF4-FFF2-40B4-BE49-F238E27FC236}">
-                <a16:creationId xmlns:a16="http://schemas.microsoft.com/office/drawing/2014/main" id="{4E774EF7-FB4D-4285-81C1-7352034420CD}"/>
+                <a16:creationId xmlns:a16="http://schemas.microsoft.com/office/drawing/2014/main" id="{9BB7B9B8-DEB0-4642-A8F4-B7000C054649}"/>
               </a:ext>
             </a:extLst>
           </p:cNvPr>
@@ -3059,7 +3059,7 @@
           <p:cNvPr id="2" name="Left column">
             <a:extLst xmlns:a="http://schemas.openxmlformats.org/drawingml/2006/main">
               <a:ext uri="{FF2B5EF4-FFF2-40B4-BE49-F238E27FC236}">
-                <a16:creationId xmlns:a16="http://schemas.microsoft.com/office/drawing/2014/main" id="{E2764875-72B2-447D-8665-40ECD71B561A}"/>
+                <a16:creationId xmlns:a16="http://schemas.microsoft.com/office/drawing/2014/main" id="{4E6746DF-A238-49C6-8F93-994FC4F8543D}"/>
               </a:ext>
             </a:extLst>
           </p:cNvPr>
@@ -3288,7 +3288,7 @@
           <p:cNvPr id="3" name="Right column">
             <a:extLst xmlns:a="http://schemas.openxmlformats.org/drawingml/2006/main">
               <a:ext uri="{FF2B5EF4-FFF2-40B4-BE49-F238E27FC236}">
-                <a16:creationId xmlns:a16="http://schemas.microsoft.com/office/drawing/2014/main" id="{1E612E20-3B09-461A-8F0D-75865511BE13}"/>
+                <a16:creationId xmlns:a16="http://schemas.microsoft.com/office/drawing/2014/main" id="{217F3408-96EB-4849-819D-61591F6FB5BE}"/>
               </a:ext>
             </a:extLst>
           </p:cNvPr>
@@ -3534,7 +3534,7 @@
           <p:cNvPr id="3" name="Title">
             <a:extLst xmlns:a="http://schemas.openxmlformats.org/drawingml/2006/main">
               <a:ext uri="{FF2B5EF4-FFF2-40B4-BE49-F238E27FC236}">
-                <a16:creationId xmlns:a16="http://schemas.microsoft.com/office/drawing/2014/main" id="{58ACA521-B84E-4512-9923-06251E6AA882}"/>
+                <a16:creationId xmlns:a16="http://schemas.microsoft.com/office/drawing/2014/main" id="{0951CBED-3BC9-41A6-8E2F-CF6610E8DACE}"/>
               </a:ext>
             </a:extLst>
           </p:cNvPr>
@@ -3763,7 +3763,7 @@
           <p:cNvPr id="2" name="Left column">
             <a:extLst xmlns:a="http://schemas.openxmlformats.org/drawingml/2006/main">
               <a:ext uri="{FF2B5EF4-FFF2-40B4-BE49-F238E27FC236}">
-                <a16:creationId xmlns:a16="http://schemas.microsoft.com/office/drawing/2014/main" id="{8361AE1F-A139-4578-BE41-CC13F2915B28}"/>
+                <a16:creationId xmlns:a16="http://schemas.microsoft.com/office/drawing/2014/main" id="{D73105B4-EA79-4C46-8C55-2775F8452B90}"/>
               </a:ext>
             </a:extLst>
           </p:cNvPr>
@@ -4030,12 +4030,12 @@
   </p:cSld>
   <p:clrMap bg1="lt1" tx1="dk1" bg2="lt2" tx2="dk2" accent1="accent1" accent2="accent2" accent3="accent3" accent4="accent4" accent5="accent5" accent6="accent6" hlink="hlink" folHlink="folHlink"/>
   <p:sldLayoutIdLst>
-    <p:sldLayoutId xmlns:r="http://schemas.openxmlformats.org/officeDocument/2006/relationships" id="2147483649" r:id="R1049790f4248443e"/>
-    <p:sldLayoutId xmlns:r="http://schemas.openxmlformats.org/officeDocument/2006/relationships" id="2147483650" r:id="R8245a17d4cad479c"/>
-    <p:sldLayoutId xmlns:r="http://schemas.openxmlformats.org/officeDocument/2006/relationships" id="2147483651" r:id="R534f3d4cefda4e72"/>
-    <p:sldLayoutId xmlns:r="http://schemas.openxmlformats.org/officeDocument/2006/relationships" id="2147483652" r:id="Rff15e3acd0424641"/>
-    <p:sldLayoutId xmlns:r="http://schemas.openxmlformats.org/officeDocument/2006/relationships" id="2147483653" r:id="R84ea0ab4bfb94ea2"/>
-    <p:sldLayoutId xmlns:r="http://schemas.openxmlformats.org/officeDocument/2006/relationships" id="2147483654" r:id="Ra3b9b55c63b044f2"/>
+    <p:sldLayoutId xmlns:r="http://schemas.openxmlformats.org/officeDocument/2006/relationships" id="2147483649" r:id="R0d8e10351abf46a1"/>
+    <p:sldLayoutId xmlns:r="http://schemas.openxmlformats.org/officeDocument/2006/relationships" id="2147483650" r:id="Re60f4fa9d76c42f0"/>
+    <p:sldLayoutId xmlns:r="http://schemas.openxmlformats.org/officeDocument/2006/relationships" id="2147483651" r:id="R4272359071a84012"/>
+    <p:sldLayoutId xmlns:r="http://schemas.openxmlformats.org/officeDocument/2006/relationships" id="2147483652" r:id="Re781aa1a12aa490b"/>
+    <p:sldLayoutId xmlns:r="http://schemas.openxmlformats.org/officeDocument/2006/relationships" id="2147483653" r:id="R7c9e043f7bd64fce"/>
+    <p:sldLayoutId xmlns:r="http://schemas.openxmlformats.org/officeDocument/2006/relationships" id="2147483654" r:id="Rd2455cf8161844a6"/>
   </p:sldLayoutIdLst>
   <p:txStyles>
     <p:titleStyle>
@@ -4586,7 +4586,7 @@
           <p:cNvPr id="7" name="">
             <a:extLst xmlns:a="http://schemas.openxmlformats.org/drawingml/2006/main">
               <a:ext uri="{FF2B5EF4-FFF2-40B4-BE49-F238E27FC236}">
-                <a16:creationId xmlns:a16="http://schemas.microsoft.com/office/drawing/2014/main" id="{E12C5C6E-2857-4EAB-8E7E-669CE84A0264}"/>
+                <a16:creationId xmlns:a16="http://schemas.microsoft.com/office/drawing/2014/main" id="{FB27DCA4-3CF4-464B-AEE0-51AB67205104}"/>
               </a:ext>
             </a:extLst>
           </p:cNvPr>
@@ -4742,7 +4742,7 @@
           <p:cNvPr id="2" name="">
             <a:extLst xmlns:a="http://schemas.openxmlformats.org/drawingml/2006/main">
               <a:ext uri="{FF2B5EF4-FFF2-40B4-BE49-F238E27FC236}">
-                <a16:creationId xmlns:a16="http://schemas.microsoft.com/office/drawing/2014/main" id="{778E8FEA-99E9-4697-9BF5-18DEDCA86227}"/>
+                <a16:creationId xmlns:a16="http://schemas.microsoft.com/office/drawing/2014/main" id="{C5D413CA-2922-4A2C-BD66-4FC87069F518}"/>
               </a:ext>
             </a:extLst>
           </p:cNvPr>
@@ -4898,7 +4898,7 @@
           <p:cNvPr id="3" name="">
             <a:extLst xmlns:a="http://schemas.openxmlformats.org/drawingml/2006/main">
               <a:ext uri="{FF2B5EF4-FFF2-40B4-BE49-F238E27FC236}">
-                <a16:creationId xmlns:a16="http://schemas.microsoft.com/office/drawing/2014/main" id="{27A989BD-C5EB-492E-B565-3CB3D43E603E}"/>
+                <a16:creationId xmlns:a16="http://schemas.microsoft.com/office/drawing/2014/main" id="{EBE0E9F6-5F78-4438-9741-F81B95AD47E6}"/>
               </a:ext>
             </a:extLst>
           </p:cNvPr>
@@ -5054,7 +5054,7 @@
           <p:cNvPr id="4" name="">
             <a:extLst xmlns:a="http://schemas.openxmlformats.org/drawingml/2006/main">
               <a:ext uri="{FF2B5EF4-FFF2-40B4-BE49-F238E27FC236}">
-                <a16:creationId xmlns:a16="http://schemas.microsoft.com/office/drawing/2014/main" id="{49F1325A-4060-43FC-A198-3EC753323CD3}"/>
+                <a16:creationId xmlns:a16="http://schemas.microsoft.com/office/drawing/2014/main" id="{BEAE72FB-9280-4B03-9406-1DECE30C1208}"/>
               </a:ext>
             </a:extLst>
           </p:cNvPr>
@@ -5210,7 +5210,7 @@
           <p:cNvPr id="5" name="">
             <a:extLst xmlns:a="http://schemas.openxmlformats.org/drawingml/2006/main">
               <a:ext uri="{FF2B5EF4-FFF2-40B4-BE49-F238E27FC236}">
-                <a16:creationId xmlns:a16="http://schemas.microsoft.com/office/drawing/2014/main" id="{C6D53834-4F69-430B-9593-3072F09CB50C}"/>
+                <a16:creationId xmlns:a16="http://schemas.microsoft.com/office/drawing/2014/main" id="{C448D79E-1A7B-477A-8DD5-4A2807EB2F08}"/>
               </a:ext>
             </a:extLst>
           </p:cNvPr>
@@ -5366,7 +5366,7 @@
           <p:cNvPr id="6" name="">
             <a:extLst xmlns:a="http://schemas.openxmlformats.org/drawingml/2006/main">
               <a:ext uri="{FF2B5EF4-FFF2-40B4-BE49-F238E27FC236}">
-                <a16:creationId xmlns:a16="http://schemas.microsoft.com/office/drawing/2014/main" id="{D431DA72-5186-4D44-A119-4DDB05922BE7}"/>
+                <a16:creationId xmlns:a16="http://schemas.microsoft.com/office/drawing/2014/main" id="{E37DE215-128B-49EF-9271-1DEE0FAF52C0}"/>
               </a:ext>
             </a:extLst>
           </p:cNvPr>
@@ -5520,7 +5520,7 @@
     </p:spTree>
     <p:extLst>
       <p:ext uri="{BB962C8B-B14F-4D97-AF65-F5344CB8AC3E}">
-        <p14:creationId xmlns:p14="http://schemas.microsoft.com/office/powerpoint/2010/main" val="716263747"/>
+        <p14:creationId xmlns:p14="http://schemas.microsoft.com/office/powerpoint/2010/main" val="1885173683"/>
       </p:ext>
     </p:extLst>
   </p:cSld>
@@ -5551,7 +5551,7 @@
           <p:cNvPr id="6" name="">
             <a:extLst xmlns:a="http://schemas.openxmlformats.org/drawingml/2006/main">
               <a:ext uri="{FF2B5EF4-FFF2-40B4-BE49-F238E27FC236}">
-                <a16:creationId xmlns:a16="http://schemas.microsoft.com/office/drawing/2014/main" id="{23DC679D-5BFE-44C1-A4C9-113A57CE946D}"/>
+                <a16:creationId xmlns:a16="http://schemas.microsoft.com/office/drawing/2014/main" id="{D07C694D-944B-4E20-8CA1-49DE665B48B6}"/>
               </a:ext>
             </a:extLst>
           </p:cNvPr>
@@ -5707,7 +5707,7 @@
           <p:cNvPr id="2" name="">
             <a:extLst xmlns:a="http://schemas.openxmlformats.org/drawingml/2006/main">
               <a:ext uri="{FF2B5EF4-FFF2-40B4-BE49-F238E27FC236}">
-                <a16:creationId xmlns:a16="http://schemas.microsoft.com/office/drawing/2014/main" id="{88A86BD4-E327-4EDC-B9AD-5B1B73ACF0B9}"/>
+                <a16:creationId xmlns:a16="http://schemas.microsoft.com/office/drawing/2014/main" id="{AF39987D-C3F8-453A-B53D-39C5B65E93EC}"/>
               </a:ext>
             </a:extLst>
           </p:cNvPr>
@@ -5863,7 +5863,7 @@
           <p:cNvPr id="3" name="">
             <a:extLst xmlns:a="http://schemas.openxmlformats.org/drawingml/2006/main">
               <a:ext uri="{FF2B5EF4-FFF2-40B4-BE49-F238E27FC236}">
-                <a16:creationId xmlns:a16="http://schemas.microsoft.com/office/drawing/2014/main" id="{39B748B3-F562-4581-AF87-C92E94AEAB0A}"/>
+                <a16:creationId xmlns:a16="http://schemas.microsoft.com/office/drawing/2014/main" id="{5354666E-1D76-4D11-A20E-B869EF868ED4}"/>
               </a:ext>
             </a:extLst>
           </p:cNvPr>
@@ -5873,7 +5873,7 @@
           <p:nvPr/>
         </p:nvPicPr>
         <p:blipFill>
-          <a:blip xmlns:r="http://schemas.openxmlformats.org/officeDocument/2006/relationships" xmlns:a="http://schemas.openxmlformats.org/drawingml/2006/main" r:embed="R4cf84a1b12f248fd"/>
+          <a:blip xmlns:r="http://schemas.openxmlformats.org/officeDocument/2006/relationships" xmlns:a="http://schemas.openxmlformats.org/drawingml/2006/main" r:embed="Ra530ca5627884ac4"/>
           <a:stretch xmlns:a="http://schemas.openxmlformats.org/drawingml/2006/main"/>
         </p:blipFill>
         <p:spPr>
@@ -5891,7 +5891,7 @@
           <p:cNvPr id="4" name="">
             <a:extLst xmlns:a="http://schemas.openxmlformats.org/drawingml/2006/main">
               <a:ext uri="{FF2B5EF4-FFF2-40B4-BE49-F238E27FC236}">
-                <a16:creationId xmlns:a16="http://schemas.microsoft.com/office/drawing/2014/main" id="{D6BCFA24-BC38-400A-8063-9E442AD412EA}"/>
+                <a16:creationId xmlns:a16="http://schemas.microsoft.com/office/drawing/2014/main" id="{E1CE707C-93C9-4844-92FF-402E9CD5F3CE}"/>
               </a:ext>
             </a:extLst>
           </p:cNvPr>
@@ -6103,7 +6103,7 @@
           <p:cNvPr id="5" name="">
             <a:extLst xmlns:a="http://schemas.openxmlformats.org/drawingml/2006/main">
               <a:ext uri="{FF2B5EF4-FFF2-40B4-BE49-F238E27FC236}">
-                <a16:creationId xmlns:a16="http://schemas.microsoft.com/office/drawing/2014/main" id="{7A319335-F9CF-4ECF-902F-6F5D1B63FAF0}"/>
+                <a16:creationId xmlns:a16="http://schemas.microsoft.com/office/drawing/2014/main" id="{2437F733-9C12-4B90-A226-62EAF4AB536C}"/>
               </a:ext>
             </a:extLst>
           </p:cNvPr>
@@ -6257,7 +6257,7 @@
     </p:spTree>
     <p:extLst>
       <p:ext uri="{BB962C8B-B14F-4D97-AF65-F5344CB8AC3E}">
-        <p14:creationId xmlns:p14="http://schemas.microsoft.com/office/powerpoint/2010/main" val="1567746028"/>
+        <p14:creationId xmlns:p14="http://schemas.microsoft.com/office/powerpoint/2010/main" val="627658653"/>
       </p:ext>
     </p:extLst>
   </p:cSld>
@@ -6288,7 +6288,7 @@
           <p:cNvPr id="5" name="">
             <a:extLst xmlns:a="http://schemas.openxmlformats.org/drawingml/2006/main">
               <a:ext uri="{FF2B5EF4-FFF2-40B4-BE49-F238E27FC236}">
-                <a16:creationId xmlns:a16="http://schemas.microsoft.com/office/drawing/2014/main" id="{F0BF6415-3648-496D-ABEE-7776758ECFCD}"/>
+                <a16:creationId xmlns:a16="http://schemas.microsoft.com/office/drawing/2014/main" id="{4665D838-A38E-4C55-A820-79322513A8E1}"/>
               </a:ext>
             </a:extLst>
           </p:cNvPr>
@@ -6444,7 +6444,7 @@
           <p:cNvPr id="2" name="">
             <a:extLst xmlns:a="http://schemas.openxmlformats.org/drawingml/2006/main">
               <a:ext uri="{FF2B5EF4-FFF2-40B4-BE49-F238E27FC236}">
-                <a16:creationId xmlns:a16="http://schemas.microsoft.com/office/drawing/2014/main" id="{5A483EAA-381C-436E-8E99-E27DD7916337}"/>
+                <a16:creationId xmlns:a16="http://schemas.microsoft.com/office/drawing/2014/main" id="{9EB41FAA-139B-4F8F-9936-137363510A15}"/>
               </a:ext>
             </a:extLst>
           </p:cNvPr>
@@ -6600,7 +6600,7 @@
           <p:cNvPr id="3" name="">
             <a:extLst xmlns:a="http://schemas.openxmlformats.org/drawingml/2006/main">
               <a:ext uri="{FF2B5EF4-FFF2-40B4-BE49-F238E27FC236}">
-                <a16:creationId xmlns:a16="http://schemas.microsoft.com/office/drawing/2014/main" id="{469E43B5-A554-499B-85C6-789D9B28A2A4}"/>
+                <a16:creationId xmlns:a16="http://schemas.microsoft.com/office/drawing/2014/main" id="{9BA506B1-93CC-438E-ABB6-71098E8430C1}"/>
               </a:ext>
             </a:extLst>
           </p:cNvPr>
@@ -7575,7 +7575,7 @@
           <p:cNvPr id="4" name="">
             <a:extLst xmlns:a="http://schemas.openxmlformats.org/drawingml/2006/main">
               <a:ext uri="{FF2B5EF4-FFF2-40B4-BE49-F238E27FC236}">
-                <a16:creationId xmlns:a16="http://schemas.microsoft.com/office/drawing/2014/main" id="{456F731A-09DC-496C-90CC-73651F4B8261}"/>
+                <a16:creationId xmlns:a16="http://schemas.microsoft.com/office/drawing/2014/main" id="{93868BA7-41DE-42A0-BD67-FC73138630A8}"/>
               </a:ext>
             </a:extLst>
           </p:cNvPr>
@@ -7729,7 +7729,7 @@
     </p:spTree>
     <p:extLst>
       <p:ext uri="{BB962C8B-B14F-4D97-AF65-F5344CB8AC3E}">
-        <p14:creationId xmlns:p14="http://schemas.microsoft.com/office/powerpoint/2010/main" val="967845714"/>
+        <p14:creationId xmlns:p14="http://schemas.microsoft.com/office/powerpoint/2010/main" val="1620733326"/>
       </p:ext>
     </p:extLst>
   </p:cSld>
@@ -7760,7 +7760,7 @@
           <p:cNvPr id="4" name="">
             <a:extLst xmlns:a="http://schemas.openxmlformats.org/drawingml/2006/main">
               <a:ext uri="{FF2B5EF4-FFF2-40B4-BE49-F238E27FC236}">
-                <a16:creationId xmlns:a16="http://schemas.microsoft.com/office/drawing/2014/main" id="{B3FD6EAE-46C7-4801-A1BF-F7983FBA77B9}"/>
+                <a16:creationId xmlns:a16="http://schemas.microsoft.com/office/drawing/2014/main" id="{FA8E2674-08E2-4E38-95EE-6B1D2447B9D2}"/>
               </a:ext>
             </a:extLst>
           </p:cNvPr>
@@ -7916,7 +7916,7 @@
           <p:cNvPr id="2" name="">
             <a:extLst xmlns:a="http://schemas.openxmlformats.org/drawingml/2006/main">
               <a:ext uri="{FF2B5EF4-FFF2-40B4-BE49-F238E27FC236}">
-                <a16:creationId xmlns:a16="http://schemas.microsoft.com/office/drawing/2014/main" id="{7600FFD3-A04F-47FE-A131-A4C45A659156}"/>
+                <a16:creationId xmlns:a16="http://schemas.microsoft.com/office/drawing/2014/main" id="{CBD87A52-87E0-44EB-81F2-35C6FF9E7292}"/>
               </a:ext>
             </a:extLst>
           </p:cNvPr>
@@ -8072,7 +8072,7 @@
           <p:cNvPr id="3" name="">
             <a:extLst xmlns:a="http://schemas.openxmlformats.org/drawingml/2006/main">
               <a:ext uri="{FF2B5EF4-FFF2-40B4-BE49-F238E27FC236}">
-                <a16:creationId xmlns:a16="http://schemas.microsoft.com/office/drawing/2014/main" id="{7B349375-71AD-4F97-99CD-32EC48B43AE4}"/>
+                <a16:creationId xmlns:a16="http://schemas.microsoft.com/office/drawing/2014/main" id="{6DE106E9-549B-4E26-A2D4-51B8F393372E}"/>
               </a:ext>
             </a:extLst>
           </p:cNvPr>
@@ -8670,7 +8670,7 @@
     </p:spTree>
     <p:extLst>
       <p:ext uri="{BB962C8B-B14F-4D97-AF65-F5344CB8AC3E}">
-        <p14:creationId xmlns:p14="http://schemas.microsoft.com/office/powerpoint/2010/main" val="946528184"/>
+        <p14:creationId xmlns:p14="http://schemas.microsoft.com/office/powerpoint/2010/main" val="1247969566"/>
       </p:ext>
     </p:extLst>
   </p:cSld>
@@ -8701,7 +8701,7 @@
           <p:cNvPr id="8" name="">
             <a:extLst xmlns:a="http://schemas.openxmlformats.org/drawingml/2006/main">
               <a:ext uri="{FF2B5EF4-FFF2-40B4-BE49-F238E27FC236}">
-                <a16:creationId xmlns:a16="http://schemas.microsoft.com/office/drawing/2014/main" id="{FEC2C059-E1C7-4B41-8C63-B54553230870}"/>
+                <a16:creationId xmlns:a16="http://schemas.microsoft.com/office/drawing/2014/main" id="{530B0B65-5D8E-4B6F-BC11-1CB48A4278EB}"/>
               </a:ext>
             </a:extLst>
           </p:cNvPr>
@@ -8857,7 +8857,7 @@
           <p:cNvPr id="2" name="">
             <a:extLst xmlns:a="http://schemas.openxmlformats.org/drawingml/2006/main">
               <a:ext uri="{FF2B5EF4-FFF2-40B4-BE49-F238E27FC236}">
-                <a16:creationId xmlns:a16="http://schemas.microsoft.com/office/drawing/2014/main" id="{B00665C6-5AB0-46EC-94AF-5DCD55E83919}"/>
+                <a16:creationId xmlns:a16="http://schemas.microsoft.com/office/drawing/2014/main" id="{AAF765C6-AEAE-444A-9B1A-AFDA11C28001}"/>
               </a:ext>
             </a:extLst>
           </p:cNvPr>
@@ -9013,7 +9013,7 @@
           <p:cNvPr id="3" name="">
             <a:extLst xmlns:a="http://schemas.openxmlformats.org/drawingml/2006/main">
               <a:ext uri="{FF2B5EF4-FFF2-40B4-BE49-F238E27FC236}">
-                <a16:creationId xmlns:a16="http://schemas.microsoft.com/office/drawing/2014/main" id="{8DDB252D-CFDB-4642-8262-86F007B17BBF}"/>
+                <a16:creationId xmlns:a16="http://schemas.microsoft.com/office/drawing/2014/main" id="{5EB5A6DB-7AEF-4F91-B7FE-26FAA884A18E}"/>
               </a:ext>
             </a:extLst>
           </p:cNvPr>
@@ -9169,7 +9169,7 @@
           <p:cNvPr id="4" name="">
             <a:extLst xmlns:a="http://schemas.openxmlformats.org/drawingml/2006/main">
               <a:ext uri="{FF2B5EF4-FFF2-40B4-BE49-F238E27FC236}">
-                <a16:creationId xmlns:a16="http://schemas.microsoft.com/office/drawing/2014/main" id="{66984973-2F05-4E22-93EB-0BAE69905673}"/>
+                <a16:creationId xmlns:a16="http://schemas.microsoft.com/office/drawing/2014/main" id="{87BF6197-0020-4856-85D2-B8C87338A3A9}"/>
               </a:ext>
             </a:extLst>
           </p:cNvPr>
@@ -9381,7 +9381,7 @@
           <p:cNvPr id="5" name="">
             <a:extLst xmlns:a="http://schemas.openxmlformats.org/drawingml/2006/main">
               <a:ext uri="{FF2B5EF4-FFF2-40B4-BE49-F238E27FC236}">
-                <a16:creationId xmlns:a16="http://schemas.microsoft.com/office/drawing/2014/main" id="{5BD3533B-8CCE-4E95-998B-FF89C731AF80}"/>
+                <a16:creationId xmlns:a16="http://schemas.microsoft.com/office/drawing/2014/main" id="{A2BF015F-A89E-4130-8CAD-C64C3B5BE764}"/>
               </a:ext>
             </a:extLst>
           </p:cNvPr>
@@ -9537,7 +9537,7 @@
           <p:cNvPr id="6" name="">
             <a:extLst xmlns:a="http://schemas.openxmlformats.org/drawingml/2006/main">
               <a:ext uri="{FF2B5EF4-FFF2-40B4-BE49-F238E27FC236}">
-                <a16:creationId xmlns:a16="http://schemas.microsoft.com/office/drawing/2014/main" id="{84E4D58F-69FE-4B61-A6CE-21FCCD53BD17}"/>
+                <a16:creationId xmlns:a16="http://schemas.microsoft.com/office/drawing/2014/main" id="{DF222E09-0002-455B-8F9A-A02D95590D24}"/>
               </a:ext>
             </a:extLst>
           </p:cNvPr>
@@ -9749,7 +9749,7 @@
           <p:cNvPr id="7" name="">
             <a:extLst xmlns:a="http://schemas.openxmlformats.org/drawingml/2006/main">
               <a:ext uri="{FF2B5EF4-FFF2-40B4-BE49-F238E27FC236}">
-                <a16:creationId xmlns:a16="http://schemas.microsoft.com/office/drawing/2014/main" id="{3400E74E-EECD-426C-8C19-7BFBC41F6221}"/>
+                <a16:creationId xmlns:a16="http://schemas.microsoft.com/office/drawing/2014/main" id="{A8CD8B05-ED43-4960-8C69-CCC941BB4B93}"/>
               </a:ext>
             </a:extLst>
           </p:cNvPr>
@@ -9903,7 +9903,7 @@
     </p:spTree>
     <p:extLst>
       <p:ext uri="{BB962C8B-B14F-4D97-AF65-F5344CB8AC3E}">
-        <p14:creationId xmlns:p14="http://schemas.microsoft.com/office/powerpoint/2010/main" val="1453516974"/>
+        <p14:creationId xmlns:p14="http://schemas.microsoft.com/office/powerpoint/2010/main" val="528776810"/>
       </p:ext>
     </p:extLst>
   </p:cSld>
@@ -9934,7 +9934,7 @@
           <p:cNvPr id="5" name="">
             <a:extLst xmlns:a="http://schemas.openxmlformats.org/drawingml/2006/main">
               <a:ext uri="{FF2B5EF4-FFF2-40B4-BE49-F238E27FC236}">
-                <a16:creationId xmlns:a16="http://schemas.microsoft.com/office/drawing/2014/main" id="{D35D8E9F-AF33-41AD-ABDB-1BFDFB42A350}"/>
+                <a16:creationId xmlns:a16="http://schemas.microsoft.com/office/drawing/2014/main" id="{1CF61F74-6A92-4824-9FA2-2FA33056CC30}"/>
               </a:ext>
             </a:extLst>
           </p:cNvPr>
@@ -10090,7 +10090,7 @@
           <p:cNvPr id="2" name="">
             <a:extLst xmlns:a="http://schemas.openxmlformats.org/drawingml/2006/main">
               <a:ext uri="{FF2B5EF4-FFF2-40B4-BE49-F238E27FC236}">
-                <a16:creationId xmlns:a16="http://schemas.microsoft.com/office/drawing/2014/main" id="{8F002A04-71C8-411B-8577-7541AFF17104}"/>
+                <a16:creationId xmlns:a16="http://schemas.microsoft.com/office/drawing/2014/main" id="{A3E5D8D9-9E00-4BBC-B497-C7D67A2EF9CC}"/>
               </a:ext>
             </a:extLst>
           </p:cNvPr>
@@ -10246,7 +10246,7 @@
           <p:cNvPr id="3" name="">
             <a:extLst xmlns:a="http://schemas.openxmlformats.org/drawingml/2006/main">
               <a:ext uri="{FF2B5EF4-FFF2-40B4-BE49-F238E27FC236}">
-                <a16:creationId xmlns:a16="http://schemas.microsoft.com/office/drawing/2014/main" id="{81E45F03-50E4-4A48-84B7-1129A28A260A}"/>
+                <a16:creationId xmlns:a16="http://schemas.microsoft.com/office/drawing/2014/main" id="{0E27BCE5-FFE1-45BC-B08E-D6B5556848A4}"/>
               </a:ext>
             </a:extLst>
           </p:cNvPr>
@@ -10989,7 +10989,7 @@
           <p:cNvPr id="4" name="">
             <a:extLst xmlns:a="http://schemas.openxmlformats.org/drawingml/2006/main">
               <a:ext uri="{FF2B5EF4-FFF2-40B4-BE49-F238E27FC236}">
-                <a16:creationId xmlns:a16="http://schemas.microsoft.com/office/drawing/2014/main" id="{54AB3382-DB03-484D-B17A-690C8374C213}"/>
+                <a16:creationId xmlns:a16="http://schemas.microsoft.com/office/drawing/2014/main" id="{CEDBC7F1-C7A5-4147-BA17-0C438DD449AB}"/>
               </a:ext>
             </a:extLst>
           </p:cNvPr>
@@ -11143,7 +11143,7 @@
     </p:spTree>
     <p:extLst>
       <p:ext uri="{BB962C8B-B14F-4D97-AF65-F5344CB8AC3E}">
-        <p14:creationId xmlns:p14="http://schemas.microsoft.com/office/powerpoint/2010/main" val="1912346941"/>
+        <p14:creationId xmlns:p14="http://schemas.microsoft.com/office/powerpoint/2010/main" val="1705532511"/>
       </p:ext>
     </p:extLst>
   </p:cSld>
@@ -11174,7 +11174,7 @@
           <p:cNvPr id="5" name="">
             <a:extLst xmlns:a="http://schemas.openxmlformats.org/drawingml/2006/main">
               <a:ext uri="{FF2B5EF4-FFF2-40B4-BE49-F238E27FC236}">
-                <a16:creationId xmlns:a16="http://schemas.microsoft.com/office/drawing/2014/main" id="{DD22D943-B2E1-475B-B782-AF4745C2502F}"/>
+                <a16:creationId xmlns:a16="http://schemas.microsoft.com/office/drawing/2014/main" id="{096EA518-8DC7-40FE-AAA8-6BD2CF750A50}"/>
               </a:ext>
             </a:extLst>
           </p:cNvPr>
@@ -11330,7 +11330,7 @@
           <p:cNvPr id="2" name="">
             <a:extLst xmlns:a="http://schemas.openxmlformats.org/drawingml/2006/main">
               <a:ext uri="{FF2B5EF4-FFF2-40B4-BE49-F238E27FC236}">
-                <a16:creationId xmlns:a16="http://schemas.microsoft.com/office/drawing/2014/main" id="{B1FBCC9F-6ECE-4C4A-8F33-CFC3D5076DC0}"/>
+                <a16:creationId xmlns:a16="http://schemas.microsoft.com/office/drawing/2014/main" id="{37783246-82DE-446F-AE80-0423847A83CE}"/>
               </a:ext>
             </a:extLst>
           </p:cNvPr>
@@ -11486,7 +11486,7 @@
           <p:cNvPr id="3" name="">
             <a:extLst xmlns:a="http://schemas.openxmlformats.org/drawingml/2006/main">
               <a:ext uri="{FF2B5EF4-FFF2-40B4-BE49-F238E27FC236}">
-                <a16:creationId xmlns:a16="http://schemas.microsoft.com/office/drawing/2014/main" id="{CB146D74-7B70-4048-BA04-03777CE676FB}"/>
+                <a16:creationId xmlns:a16="http://schemas.microsoft.com/office/drawing/2014/main" id="{D3FB9872-C1EE-43DE-8775-F23F98031BCD}"/>
               </a:ext>
             </a:extLst>
           </p:cNvPr>
@@ -12006,7 +12006,7 @@
           <p:cNvPr id="4" name="">
             <a:extLst xmlns:a="http://schemas.openxmlformats.org/drawingml/2006/main">
               <a:ext uri="{FF2B5EF4-FFF2-40B4-BE49-F238E27FC236}">
-                <a16:creationId xmlns:a16="http://schemas.microsoft.com/office/drawing/2014/main" id="{47C74C13-4BC2-4E87-A137-120C4327D368}"/>
+                <a16:creationId xmlns:a16="http://schemas.microsoft.com/office/drawing/2014/main" id="{915A5DDE-32C8-4E95-AD4D-9BC9CDF99026}"/>
               </a:ext>
             </a:extLst>
           </p:cNvPr>
@@ -12160,7 +12160,7 @@
     </p:spTree>
     <p:extLst>
       <p:ext uri="{BB962C8B-B14F-4D97-AF65-F5344CB8AC3E}">
-        <p14:creationId xmlns:p14="http://schemas.microsoft.com/office/powerpoint/2010/main" val="683245599"/>
+        <p14:creationId xmlns:p14="http://schemas.microsoft.com/office/powerpoint/2010/main" val="610237372"/>
       </p:ext>
     </p:extLst>
   </p:cSld>
@@ -12191,7 +12191,7 @@
           <p:cNvPr id="9" name="">
             <a:extLst xmlns:a="http://schemas.openxmlformats.org/drawingml/2006/main">
               <a:ext uri="{FF2B5EF4-FFF2-40B4-BE49-F238E27FC236}">
-                <a16:creationId xmlns:a16="http://schemas.microsoft.com/office/drawing/2014/main" id="{3A111A88-5FDD-4BC0-8AB6-F2D916DE108D}"/>
+                <a16:creationId xmlns:a16="http://schemas.microsoft.com/office/drawing/2014/main" id="{C78721B7-8CF5-4736-9354-5FEC0F39CB29}"/>
               </a:ext>
             </a:extLst>
           </p:cNvPr>
@@ -12347,7 +12347,7 @@
           <p:cNvPr id="2" name="">
             <a:extLst xmlns:a="http://schemas.openxmlformats.org/drawingml/2006/main">
               <a:ext uri="{FF2B5EF4-FFF2-40B4-BE49-F238E27FC236}">
-                <a16:creationId xmlns:a16="http://schemas.microsoft.com/office/drawing/2014/main" id="{7E6DC16C-39C9-40AA-BE16-1A3EB9CD90DC}"/>
+                <a16:creationId xmlns:a16="http://schemas.microsoft.com/office/drawing/2014/main" id="{16624F8D-1CF7-47D1-8C81-8807735FFC8A}"/>
               </a:ext>
             </a:extLst>
           </p:cNvPr>
@@ -12503,7 +12503,7 @@
           <p:cNvPr id="3" name="">
             <a:extLst xmlns:a="http://schemas.openxmlformats.org/drawingml/2006/main">
               <a:ext uri="{FF2B5EF4-FFF2-40B4-BE49-F238E27FC236}">
-                <a16:creationId xmlns:a16="http://schemas.microsoft.com/office/drawing/2014/main" id="{BD093BFF-108A-4D2C-8EC8-DFE579136102}"/>
+                <a16:creationId xmlns:a16="http://schemas.microsoft.com/office/drawing/2014/main" id="{8B8FD7D3-F356-4F8E-9684-63536F0DEEDA}"/>
               </a:ext>
             </a:extLst>
           </p:cNvPr>
@@ -12659,7 +12659,7 @@
           <p:cNvPr id="4" name="">
             <a:extLst xmlns:a="http://schemas.openxmlformats.org/drawingml/2006/main">
               <a:ext uri="{FF2B5EF4-FFF2-40B4-BE49-F238E27FC236}">
-                <a16:creationId xmlns:a16="http://schemas.microsoft.com/office/drawing/2014/main" id="{F1FBEE5C-8757-48D0-92AA-D2DA387088AA}"/>
+                <a16:creationId xmlns:a16="http://schemas.microsoft.com/office/drawing/2014/main" id="{88E50F8C-742B-4090-BFF4-673BDC5A2797}"/>
               </a:ext>
             </a:extLst>
           </p:cNvPr>
@@ -12815,7 +12815,7 @@
           <p:cNvPr id="5" name="">
             <a:extLst xmlns:a="http://schemas.openxmlformats.org/drawingml/2006/main">
               <a:ext uri="{FF2B5EF4-FFF2-40B4-BE49-F238E27FC236}">
-                <a16:creationId xmlns:a16="http://schemas.microsoft.com/office/drawing/2014/main" id="{A3D2783D-59A5-4E0D-831C-0229B43CCE82}"/>
+                <a16:creationId xmlns:a16="http://schemas.microsoft.com/office/drawing/2014/main" id="{DEE834A3-6B68-4B31-9167-6AC39B195381}"/>
               </a:ext>
             </a:extLst>
           </p:cNvPr>
@@ -12971,7 +12971,7 @@
           <p:cNvPr id="6" name="">
             <a:extLst xmlns:a="http://schemas.openxmlformats.org/drawingml/2006/main">
               <a:ext uri="{FF2B5EF4-FFF2-40B4-BE49-F238E27FC236}">
-                <a16:creationId xmlns:a16="http://schemas.microsoft.com/office/drawing/2014/main" id="{672E336E-95D6-4EE8-A8DC-B35FF618032B}"/>
+                <a16:creationId xmlns:a16="http://schemas.microsoft.com/office/drawing/2014/main" id="{2A3345CC-754D-49AB-A650-0442B44E552B}"/>
               </a:ext>
             </a:extLst>
           </p:cNvPr>
@@ -13127,7 +13127,7 @@
           <p:cNvPr id="7" name="">
             <a:extLst xmlns:a="http://schemas.openxmlformats.org/drawingml/2006/main">
               <a:ext uri="{FF2B5EF4-FFF2-40B4-BE49-F238E27FC236}">
-                <a16:creationId xmlns:a16="http://schemas.microsoft.com/office/drawing/2014/main" id="{E56F419A-E69F-4D67-AC1E-501D40C0F19D}"/>
+                <a16:creationId xmlns:a16="http://schemas.microsoft.com/office/drawing/2014/main" id="{0121FFB4-51D8-45B7-B275-DF34D93C9F32}"/>
               </a:ext>
             </a:extLst>
           </p:cNvPr>
@@ -13283,7 +13283,7 @@
           <p:cNvPr id="8" name="">
             <a:extLst xmlns:a="http://schemas.openxmlformats.org/drawingml/2006/main">
               <a:ext uri="{FF2B5EF4-FFF2-40B4-BE49-F238E27FC236}">
-                <a16:creationId xmlns:a16="http://schemas.microsoft.com/office/drawing/2014/main" id="{5ED17A07-C369-4FB2-AD2B-9D9C00ABD884}"/>
+                <a16:creationId xmlns:a16="http://schemas.microsoft.com/office/drawing/2014/main" id="{5DDFD13E-4387-40F4-9228-6A3B465A85C2}"/>
               </a:ext>
             </a:extLst>
           </p:cNvPr>
@@ -13437,7 +13437,7 @@
     </p:spTree>
     <p:extLst>
       <p:ext uri="{BB962C8B-B14F-4D97-AF65-F5344CB8AC3E}">
-        <p14:creationId xmlns:p14="http://schemas.microsoft.com/office/powerpoint/2010/main" val="71646393"/>
+        <p14:creationId xmlns:p14="http://schemas.microsoft.com/office/powerpoint/2010/main" val="480841402"/>
       </p:ext>
     </p:extLst>
   </p:cSld>
@@ -13468,7 +13468,7 @@
           <p:cNvPr id="7" name="">
             <a:extLst xmlns:a="http://schemas.openxmlformats.org/drawingml/2006/main">
               <a:ext uri="{FF2B5EF4-FFF2-40B4-BE49-F238E27FC236}">
-                <a16:creationId xmlns:a16="http://schemas.microsoft.com/office/drawing/2014/main" id="{00418937-FCD1-404C-81AF-2305EB77EB84}"/>
+                <a16:creationId xmlns:a16="http://schemas.microsoft.com/office/drawing/2014/main" id="{F017021F-8700-4A53-9FE1-20412D1E5388}"/>
               </a:ext>
             </a:extLst>
           </p:cNvPr>
@@ -13624,7 +13624,7 @@
           <p:cNvPr id="2" name="">
             <a:extLst xmlns:a="http://schemas.openxmlformats.org/drawingml/2006/main">
               <a:ext uri="{FF2B5EF4-FFF2-40B4-BE49-F238E27FC236}">
-                <a16:creationId xmlns:a16="http://schemas.microsoft.com/office/drawing/2014/main" id="{7F67AA6A-D682-4FD5-A0E5-AE8008A3EC23}"/>
+                <a16:creationId xmlns:a16="http://schemas.microsoft.com/office/drawing/2014/main" id="{C0857F82-6F9F-45EF-BE10-E9FB4BA77E66}"/>
               </a:ext>
             </a:extLst>
           </p:cNvPr>
@@ -13780,7 +13780,7 @@
           <p:cNvPr id="3" name="">
             <a:extLst xmlns:a="http://schemas.openxmlformats.org/drawingml/2006/main">
               <a:ext uri="{FF2B5EF4-FFF2-40B4-BE49-F238E27FC236}">
-                <a16:creationId xmlns:a16="http://schemas.microsoft.com/office/drawing/2014/main" id="{3F00A82E-C283-4395-930C-BC444B9637C8}"/>
+                <a16:creationId xmlns:a16="http://schemas.microsoft.com/office/drawing/2014/main" id="{21FF3130-6511-4B6E-BC81-3076E25AFF2C}"/>
               </a:ext>
             </a:extLst>
           </p:cNvPr>
@@ -13936,7 +13936,7 @@
           <p:cNvPr id="4" name="">
             <a:extLst xmlns:a="http://schemas.openxmlformats.org/drawingml/2006/main">
               <a:ext uri="{FF2B5EF4-FFF2-40B4-BE49-F238E27FC236}">
-                <a16:creationId xmlns:a16="http://schemas.microsoft.com/office/drawing/2014/main" id="{822C8AD6-6C3F-48DD-9A81-B60D0B16D188}"/>
+                <a16:creationId xmlns:a16="http://schemas.microsoft.com/office/drawing/2014/main" id="{B5352DDD-9000-4CE1-BAA7-5E8CD113B855}"/>
               </a:ext>
             </a:extLst>
           </p:cNvPr>
@@ -14092,7 +14092,7 @@
           <p:cNvPr id="5" name="">
             <a:extLst xmlns:a="http://schemas.openxmlformats.org/drawingml/2006/main">
               <a:ext uri="{FF2B5EF4-FFF2-40B4-BE49-F238E27FC236}">
-                <a16:creationId xmlns:a16="http://schemas.microsoft.com/office/drawing/2014/main" id="{A118456C-B3C5-4E97-B33E-E16A99ECB2C9}"/>
+                <a16:creationId xmlns:a16="http://schemas.microsoft.com/office/drawing/2014/main" id="{561E0CFF-ED8E-4BA5-B622-E93B452C21BD}"/>
               </a:ext>
             </a:extLst>
           </p:cNvPr>
@@ -14102,7 +14102,7 @@
           <p:nvPr/>
         </p:nvPicPr>
         <p:blipFill>
-          <a:blip xmlns:r="http://schemas.openxmlformats.org/officeDocument/2006/relationships" xmlns:a="http://schemas.openxmlformats.org/drawingml/2006/main" r:embed="Ra2e1990ff4454486"/>
+          <a:blip xmlns:r="http://schemas.openxmlformats.org/officeDocument/2006/relationships" xmlns:a="http://schemas.openxmlformats.org/drawingml/2006/main" r:embed="R52cb3c6b53e745cc"/>
           <a:stretch xmlns:a="http://schemas.openxmlformats.org/drawingml/2006/main"/>
         </p:blipFill>
         <p:spPr>
@@ -14120,7 +14120,7 @@
           <p:cNvPr id="6" name="">
             <a:extLst xmlns:a="http://schemas.openxmlformats.org/drawingml/2006/main">
               <a:ext uri="{FF2B5EF4-FFF2-40B4-BE49-F238E27FC236}">
-                <a16:creationId xmlns:a16="http://schemas.microsoft.com/office/drawing/2014/main" id="{B5FB3519-E3E0-4253-87AD-942BFF0F4F27}"/>
+                <a16:creationId xmlns:a16="http://schemas.microsoft.com/office/drawing/2014/main" id="{08728DA2-95D6-488C-A811-4776A2DFCDAA}"/>
               </a:ext>
             </a:extLst>
           </p:cNvPr>
@@ -14274,7 +14274,7 @@
     </p:spTree>
     <p:extLst>
       <p:ext uri="{BB962C8B-B14F-4D97-AF65-F5344CB8AC3E}">
-        <p14:creationId xmlns:p14="http://schemas.microsoft.com/office/powerpoint/2010/main" val="1514300003"/>
+        <p14:creationId xmlns:p14="http://schemas.microsoft.com/office/powerpoint/2010/main" val="2104133197"/>
       </p:ext>
     </p:extLst>
   </p:cSld>
@@ -14305,7 +14305,7 @@
           <p:cNvPr id="4" name="">
             <a:extLst xmlns:a="http://schemas.openxmlformats.org/drawingml/2006/main">
               <a:ext uri="{FF2B5EF4-FFF2-40B4-BE49-F238E27FC236}">
-                <a16:creationId xmlns:a16="http://schemas.microsoft.com/office/drawing/2014/main" id="{9E44E931-5AF7-4E4D-AB30-D83D0415671E}"/>
+                <a16:creationId xmlns:a16="http://schemas.microsoft.com/office/drawing/2014/main" id="{3429017A-6193-4921-9F68-2E0370D01115}"/>
               </a:ext>
             </a:extLst>
           </p:cNvPr>
@@ -14461,7 +14461,7 @@
           <p:cNvPr id="2" name="">
             <a:extLst xmlns:a="http://schemas.openxmlformats.org/drawingml/2006/main">
               <a:ext uri="{FF2B5EF4-FFF2-40B4-BE49-F238E27FC236}">
-                <a16:creationId xmlns:a16="http://schemas.microsoft.com/office/drawing/2014/main" id="{20D90E36-DCDC-49CF-86ED-2DD0812FFFB6}"/>
+                <a16:creationId xmlns:a16="http://schemas.microsoft.com/office/drawing/2014/main" id="{05ECA295-B178-4BC1-BC93-C375F0627360}"/>
               </a:ext>
             </a:extLst>
           </p:cNvPr>
@@ -14617,7 +14617,7 @@
           <p:cNvPr id="3" name="">
             <a:extLst xmlns:a="http://schemas.openxmlformats.org/drawingml/2006/main">
               <a:ext uri="{FF2B5EF4-FFF2-40B4-BE49-F238E27FC236}">
-                <a16:creationId xmlns:a16="http://schemas.microsoft.com/office/drawing/2014/main" id="{34E40726-3773-4CD9-B52D-C7EEB1364C43}"/>
+                <a16:creationId xmlns:a16="http://schemas.microsoft.com/office/drawing/2014/main" id="{AF71B520-FD78-40E7-96FE-2724DDA6387C}"/>
               </a:ext>
             </a:extLst>
           </p:cNvPr>
@@ -15215,7 +15215,7 @@
     </p:spTree>
     <p:extLst>
       <p:ext uri="{BB962C8B-B14F-4D97-AF65-F5344CB8AC3E}">
-        <p14:creationId xmlns:p14="http://schemas.microsoft.com/office/powerpoint/2010/main" val="1250814580"/>
+        <p14:creationId xmlns:p14="http://schemas.microsoft.com/office/powerpoint/2010/main" val="1722487510"/>
       </p:ext>
     </p:extLst>
   </p:cSld>
@@ -15246,7 +15246,7 @@
           <p:cNvPr id="8" name="">
             <a:extLst xmlns:a="http://schemas.openxmlformats.org/drawingml/2006/main">
               <a:ext uri="{FF2B5EF4-FFF2-40B4-BE49-F238E27FC236}">
-                <a16:creationId xmlns:a16="http://schemas.microsoft.com/office/drawing/2014/main" id="{961C1D4D-129A-4FE7-96BA-12473BCA539D}"/>
+                <a16:creationId xmlns:a16="http://schemas.microsoft.com/office/drawing/2014/main" id="{ADF61038-913F-493E-A10A-3E3AC12BCFDC}"/>
               </a:ext>
             </a:extLst>
           </p:cNvPr>
@@ -15402,7 +15402,7 @@
           <p:cNvPr id="2" name="">
             <a:extLst xmlns:a="http://schemas.openxmlformats.org/drawingml/2006/main">
               <a:ext uri="{FF2B5EF4-FFF2-40B4-BE49-F238E27FC236}">
-                <a16:creationId xmlns:a16="http://schemas.microsoft.com/office/drawing/2014/main" id="{446C1417-F47E-4C32-9637-FFBC145900A2}"/>
+                <a16:creationId xmlns:a16="http://schemas.microsoft.com/office/drawing/2014/main" id="{23537CBF-263C-4946-BFFD-2D7DAD7AD866}"/>
               </a:ext>
             </a:extLst>
           </p:cNvPr>
@@ -15558,7 +15558,7 @@
           <p:cNvPr id="3" name="">
             <a:extLst xmlns:a="http://schemas.openxmlformats.org/drawingml/2006/main">
               <a:ext uri="{FF2B5EF4-FFF2-40B4-BE49-F238E27FC236}">
-                <a16:creationId xmlns:a16="http://schemas.microsoft.com/office/drawing/2014/main" id="{4C692EA5-7B49-41CC-806F-14BB18EA3115}"/>
+                <a16:creationId xmlns:a16="http://schemas.microsoft.com/office/drawing/2014/main" id="{7F19559C-130B-44D9-8FE6-799C637CC9B3}"/>
               </a:ext>
             </a:extLst>
           </p:cNvPr>
@@ -15714,7 +15714,7 @@
           <p:cNvPr id="4" name="">
             <a:extLst xmlns:a="http://schemas.openxmlformats.org/drawingml/2006/main">
               <a:ext uri="{FF2B5EF4-FFF2-40B4-BE49-F238E27FC236}">
-                <a16:creationId xmlns:a16="http://schemas.microsoft.com/office/drawing/2014/main" id="{09C8CB00-D607-4355-B0AA-883F015D62E7}"/>
+                <a16:creationId xmlns:a16="http://schemas.microsoft.com/office/drawing/2014/main" id="{872480D0-C45B-4B47-BEC2-573B75054218}"/>
               </a:ext>
             </a:extLst>
           </p:cNvPr>
@@ -15893,7 +15893,7 @@
           <p:cNvPr id="5" name="">
             <a:extLst xmlns:a="http://schemas.openxmlformats.org/drawingml/2006/main">
               <a:ext uri="{FF2B5EF4-FFF2-40B4-BE49-F238E27FC236}">
-                <a16:creationId xmlns:a16="http://schemas.microsoft.com/office/drawing/2014/main" id="{0E6EDF67-C0A6-42AE-8577-44C20A9FA3AB}"/>
+                <a16:creationId xmlns:a16="http://schemas.microsoft.com/office/drawing/2014/main" id="{6D7172BC-A52E-4F9E-96FD-A89751BCC492}"/>
               </a:ext>
             </a:extLst>
           </p:cNvPr>
@@ -16049,7 +16049,7 @@
           <p:cNvPr id="6" name="">
             <a:extLst xmlns:a="http://schemas.openxmlformats.org/drawingml/2006/main">
               <a:ext uri="{FF2B5EF4-FFF2-40B4-BE49-F238E27FC236}">
-                <a16:creationId xmlns:a16="http://schemas.microsoft.com/office/drawing/2014/main" id="{73CA8475-7E90-4E7A-A438-163DF7E33DF5}"/>
+                <a16:creationId xmlns:a16="http://schemas.microsoft.com/office/drawing/2014/main" id="{26C630B2-6C9A-4595-8CF0-463E8362769B}"/>
               </a:ext>
             </a:extLst>
           </p:cNvPr>
@@ -16059,7 +16059,7 @@
           <p:nvPr/>
         </p:nvPicPr>
         <p:blipFill>
-          <a:blip xmlns:r="http://schemas.openxmlformats.org/officeDocument/2006/relationships" xmlns:a="http://schemas.openxmlformats.org/drawingml/2006/main" r:embed="Rd8aa1f9b89c143d3"/>
+          <a:blip xmlns:r="http://schemas.openxmlformats.org/officeDocument/2006/relationships" xmlns:a="http://schemas.openxmlformats.org/drawingml/2006/main" r:embed="R4f80778bef6b475c"/>
           <a:stretch xmlns:a="http://schemas.openxmlformats.org/drawingml/2006/main"/>
         </p:blipFill>
         <p:spPr>
@@ -16077,7 +16077,7 @@
           <p:cNvPr id="7" name="">
             <a:extLst xmlns:a="http://schemas.openxmlformats.org/drawingml/2006/main">
               <a:ext uri="{FF2B5EF4-FFF2-40B4-BE49-F238E27FC236}">
-                <a16:creationId xmlns:a16="http://schemas.microsoft.com/office/drawing/2014/main" id="{500581AC-8637-4E04-91B5-937D8BF33C83}"/>
+                <a16:creationId xmlns:a16="http://schemas.microsoft.com/office/drawing/2014/main" id="{D658CBBA-6B52-41E3-9A7D-F14B3304A5EF}"/>
               </a:ext>
             </a:extLst>
           </p:cNvPr>
@@ -16231,7 +16231,7 @@
     </p:spTree>
     <p:extLst>
       <p:ext uri="{BB962C8B-B14F-4D97-AF65-F5344CB8AC3E}">
-        <p14:creationId xmlns:p14="http://schemas.microsoft.com/office/powerpoint/2010/main" val="2084213208"/>
+        <p14:creationId xmlns:p14="http://schemas.microsoft.com/office/powerpoint/2010/main" val="2035342276"/>
       </p:ext>
     </p:extLst>
   </p:cSld>
@@ -16262,7 +16262,7 @@
           <p:cNvPr id="5" name="">
             <a:extLst xmlns:a="http://schemas.openxmlformats.org/drawingml/2006/main">
               <a:ext uri="{FF2B5EF4-FFF2-40B4-BE49-F238E27FC236}">
-                <a16:creationId xmlns:a16="http://schemas.microsoft.com/office/drawing/2014/main" id="{FC6E7004-620F-49FA-ADC7-A1B9BC53D5E5}"/>
+                <a16:creationId xmlns:a16="http://schemas.microsoft.com/office/drawing/2014/main" id="{13957E19-AE94-4D87-8D6C-F29EAFC9CD49}"/>
               </a:ext>
             </a:extLst>
           </p:cNvPr>
@@ -16418,7 +16418,7 @@
           <p:cNvPr id="2" name="">
             <a:extLst xmlns:a="http://schemas.openxmlformats.org/drawingml/2006/main">
               <a:ext uri="{FF2B5EF4-FFF2-40B4-BE49-F238E27FC236}">
-                <a16:creationId xmlns:a16="http://schemas.microsoft.com/office/drawing/2014/main" id="{DF0147BF-FEA3-415F-867D-41039B9E1E94}"/>
+                <a16:creationId xmlns:a16="http://schemas.microsoft.com/office/drawing/2014/main" id="{F7FA2F7B-5024-4611-AFC9-FEC23EFCB180}"/>
               </a:ext>
             </a:extLst>
           </p:cNvPr>
@@ -16574,7 +16574,7 @@
           <p:cNvPr id="3" name="">
             <a:extLst xmlns:a="http://schemas.openxmlformats.org/drawingml/2006/main">
               <a:ext uri="{FF2B5EF4-FFF2-40B4-BE49-F238E27FC236}">
-                <a16:creationId xmlns:a16="http://schemas.microsoft.com/office/drawing/2014/main" id="{79ACE6C4-44AF-427B-9974-367014F46130}"/>
+                <a16:creationId xmlns:a16="http://schemas.microsoft.com/office/drawing/2014/main" id="{CFF95815-4435-4984-B5B4-2BC0CA0EE3A8}"/>
               </a:ext>
             </a:extLst>
           </p:cNvPr>
@@ -17540,7 +17540,7 @@
           <p:cNvPr id="4" name="">
             <a:extLst xmlns:a="http://schemas.openxmlformats.org/drawingml/2006/main">
               <a:ext uri="{FF2B5EF4-FFF2-40B4-BE49-F238E27FC236}">
-                <a16:creationId xmlns:a16="http://schemas.microsoft.com/office/drawing/2014/main" id="{5FFF23C1-3773-4E2C-B787-858FF3841030}"/>
+                <a16:creationId xmlns:a16="http://schemas.microsoft.com/office/drawing/2014/main" id="{BF27ED16-0E52-48D9-9829-FF6F4FD30953}"/>
               </a:ext>
             </a:extLst>
           </p:cNvPr>
@@ -17694,7 +17694,7 @@
     </p:spTree>
     <p:extLst>
       <p:ext uri="{BB962C8B-B14F-4D97-AF65-F5344CB8AC3E}">
-        <p14:creationId xmlns:p14="http://schemas.microsoft.com/office/powerpoint/2010/main" val="720713784"/>
+        <p14:creationId xmlns:p14="http://schemas.microsoft.com/office/powerpoint/2010/main" val="1754679022"/>
       </p:ext>
     </p:extLst>
   </p:cSld>
@@ -17725,7 +17725,7 @@
           <p:cNvPr id="19" name="">
             <a:extLst xmlns:a="http://schemas.openxmlformats.org/drawingml/2006/main">
               <a:ext uri="{FF2B5EF4-FFF2-40B4-BE49-F238E27FC236}">
-                <a16:creationId xmlns:a16="http://schemas.microsoft.com/office/drawing/2014/main" id="{21637A5E-90BC-4877-AEF7-385CFEC4F866}"/>
+                <a16:creationId xmlns:a16="http://schemas.microsoft.com/office/drawing/2014/main" id="{2A710310-8881-43DB-8832-1CCCA5E82543}"/>
               </a:ext>
             </a:extLst>
           </p:cNvPr>
@@ -17881,7 +17881,7 @@
           <p:cNvPr id="2" name="">
             <a:extLst xmlns:a="http://schemas.openxmlformats.org/drawingml/2006/main">
               <a:ext uri="{FF2B5EF4-FFF2-40B4-BE49-F238E27FC236}">
-                <a16:creationId xmlns:a16="http://schemas.microsoft.com/office/drawing/2014/main" id="{739F9E60-2AAD-457E-99A6-B1C5C7BE98B7}"/>
+                <a16:creationId xmlns:a16="http://schemas.microsoft.com/office/drawing/2014/main" id="{3EFB2B75-D5A6-4C38-9BF0-BE2E4DC7467B}"/>
               </a:ext>
             </a:extLst>
           </p:cNvPr>
@@ -18037,7 +18037,7 @@
           <p:cNvPr id="3" name="">
             <a:extLst xmlns:a="http://schemas.openxmlformats.org/drawingml/2006/main">
               <a:ext uri="{FF2B5EF4-FFF2-40B4-BE49-F238E27FC236}">
-                <a16:creationId xmlns:a16="http://schemas.microsoft.com/office/drawing/2014/main" id="{E2053C1F-9DF1-4EB9-AC34-7E3C834ED8A4}"/>
+                <a16:creationId xmlns:a16="http://schemas.microsoft.com/office/drawing/2014/main" id="{B5002EEE-31AE-4E8B-A490-B74599769DD5}"/>
               </a:ext>
             </a:extLst>
           </p:cNvPr>
@@ -18069,7 +18069,7 @@
           <p:cNvPr id="4" name="">
             <a:extLst xmlns:a="http://schemas.openxmlformats.org/drawingml/2006/main">
               <a:ext uri="{FF2B5EF4-FFF2-40B4-BE49-F238E27FC236}">
-                <a16:creationId xmlns:a16="http://schemas.microsoft.com/office/drawing/2014/main" id="{3CA6612F-F608-4709-805A-1B6081DE5E9B}"/>
+                <a16:creationId xmlns:a16="http://schemas.microsoft.com/office/drawing/2014/main" id="{E0089C96-FFB3-45D3-ABE5-1F1478BB72FC}"/>
               </a:ext>
             </a:extLst>
           </p:cNvPr>
@@ -18225,7 +18225,7 @@
           <p:cNvPr id="5" name="">
             <a:extLst xmlns:a="http://schemas.openxmlformats.org/drawingml/2006/main">
               <a:ext uri="{FF2B5EF4-FFF2-40B4-BE49-F238E27FC236}">
-                <a16:creationId xmlns:a16="http://schemas.microsoft.com/office/drawing/2014/main" id="{EC320711-AB91-42CB-9B14-E0C60A324A45}"/>
+                <a16:creationId xmlns:a16="http://schemas.microsoft.com/office/drawing/2014/main" id="{CF1D1669-3CD6-4AE3-B244-87839405D921}"/>
               </a:ext>
             </a:extLst>
           </p:cNvPr>
@@ -18404,7 +18404,7 @@
           <p:cNvPr id="6" name="">
             <a:extLst xmlns:a="http://schemas.openxmlformats.org/drawingml/2006/main">
               <a:ext uri="{FF2B5EF4-FFF2-40B4-BE49-F238E27FC236}">
-                <a16:creationId xmlns:a16="http://schemas.microsoft.com/office/drawing/2014/main" id="{0E029466-F82E-4D12-B078-4E46CA6E2BA3}"/>
+                <a16:creationId xmlns:a16="http://schemas.microsoft.com/office/drawing/2014/main" id="{3B630A8F-E95B-427D-BCB8-D57428B84289}"/>
               </a:ext>
             </a:extLst>
           </p:cNvPr>
@@ -18436,7 +18436,7 @@
           <p:cNvPr id="7" name="">
             <a:extLst xmlns:a="http://schemas.openxmlformats.org/drawingml/2006/main">
               <a:ext uri="{FF2B5EF4-FFF2-40B4-BE49-F238E27FC236}">
-                <a16:creationId xmlns:a16="http://schemas.microsoft.com/office/drawing/2014/main" id="{2897462B-256C-42B5-97A0-FAC4EDD74703}"/>
+                <a16:creationId xmlns:a16="http://schemas.microsoft.com/office/drawing/2014/main" id="{7665A47B-B783-41C1-B4B0-B48EFCAA25B8}"/>
               </a:ext>
             </a:extLst>
           </p:cNvPr>
@@ -18592,7 +18592,7 @@
           <p:cNvPr id="8" name="">
             <a:extLst xmlns:a="http://schemas.openxmlformats.org/drawingml/2006/main">
               <a:ext uri="{FF2B5EF4-FFF2-40B4-BE49-F238E27FC236}">
-                <a16:creationId xmlns:a16="http://schemas.microsoft.com/office/drawing/2014/main" id="{9801B7CD-C58E-440B-820C-6FB2EFF7AC2B}"/>
+                <a16:creationId xmlns:a16="http://schemas.microsoft.com/office/drawing/2014/main" id="{9AC2D45B-D509-4FC3-B7F8-7A5C87497DC6}"/>
               </a:ext>
             </a:extLst>
           </p:cNvPr>
@@ -18771,7 +18771,7 @@
           <p:cNvPr id="9" name="">
             <a:extLst xmlns:a="http://schemas.openxmlformats.org/drawingml/2006/main">
               <a:ext uri="{FF2B5EF4-FFF2-40B4-BE49-F238E27FC236}">
-                <a16:creationId xmlns:a16="http://schemas.microsoft.com/office/drawing/2014/main" id="{88328CD1-78CB-4089-AB55-15C59831D340}"/>
+                <a16:creationId xmlns:a16="http://schemas.microsoft.com/office/drawing/2014/main" id="{DFE36210-F671-47B7-9935-E6D09EAA873C}"/>
               </a:ext>
             </a:extLst>
           </p:cNvPr>
@@ -18803,7 +18803,7 @@
           <p:cNvPr id="10" name="">
             <a:extLst xmlns:a="http://schemas.openxmlformats.org/drawingml/2006/main">
               <a:ext uri="{FF2B5EF4-FFF2-40B4-BE49-F238E27FC236}">
-                <a16:creationId xmlns:a16="http://schemas.microsoft.com/office/drawing/2014/main" id="{333C8C7B-FA79-426F-B7D1-D45896BA3FFB}"/>
+                <a16:creationId xmlns:a16="http://schemas.microsoft.com/office/drawing/2014/main" id="{0AFBB472-062E-464C-A1DF-73ACE7500928}"/>
               </a:ext>
             </a:extLst>
           </p:cNvPr>
@@ -18959,7 +18959,7 @@
           <p:cNvPr id="11" name="">
             <a:extLst xmlns:a="http://schemas.openxmlformats.org/drawingml/2006/main">
               <a:ext uri="{FF2B5EF4-FFF2-40B4-BE49-F238E27FC236}">
-                <a16:creationId xmlns:a16="http://schemas.microsoft.com/office/drawing/2014/main" id="{1B2DAD05-54F2-40C5-A5B8-0F9C40907D33}"/>
+                <a16:creationId xmlns:a16="http://schemas.microsoft.com/office/drawing/2014/main" id="{DDFEB044-BD38-494A-B65D-58FB17C7CB15}"/>
               </a:ext>
             </a:extLst>
           </p:cNvPr>
@@ -19138,7 +19138,7 @@
           <p:cNvPr id="12" name="">
             <a:extLst xmlns:a="http://schemas.openxmlformats.org/drawingml/2006/main">
               <a:ext uri="{FF2B5EF4-FFF2-40B4-BE49-F238E27FC236}">
-                <a16:creationId xmlns:a16="http://schemas.microsoft.com/office/drawing/2014/main" id="{675DF1DD-40C0-40F8-A10D-39D473E53507}"/>
+                <a16:creationId xmlns:a16="http://schemas.microsoft.com/office/drawing/2014/main" id="{F860C34A-9921-4DF0-80FE-BBB8D2A695C9}"/>
               </a:ext>
             </a:extLst>
           </p:cNvPr>
@@ -19168,7 +19168,7 @@
           <p:cNvPr id="13" name="">
             <a:extLst xmlns:a="http://schemas.openxmlformats.org/drawingml/2006/main">
               <a:ext uri="{FF2B5EF4-FFF2-40B4-BE49-F238E27FC236}">
-                <a16:creationId xmlns:a16="http://schemas.microsoft.com/office/drawing/2014/main" id="{CB3CED20-C9DA-43AD-B171-E27D0220452A}"/>
+                <a16:creationId xmlns:a16="http://schemas.microsoft.com/office/drawing/2014/main" id="{2A6D86FA-6EB6-4795-AE3F-C8CA9A3666EF}"/>
               </a:ext>
             </a:extLst>
           </p:cNvPr>
@@ -19198,7 +19198,7 @@
           <p:cNvPr id="14" name="">
             <a:extLst xmlns:a="http://schemas.openxmlformats.org/drawingml/2006/main">
               <a:ext uri="{FF2B5EF4-FFF2-40B4-BE49-F238E27FC236}">
-                <a16:creationId xmlns:a16="http://schemas.microsoft.com/office/drawing/2014/main" id="{DCF14FDA-666E-43ED-97C0-ED1F5615A8D9}"/>
+                <a16:creationId xmlns:a16="http://schemas.microsoft.com/office/drawing/2014/main" id="{AF32B589-C76B-47FA-A789-00CB4FDD553A}"/>
               </a:ext>
             </a:extLst>
           </p:cNvPr>
@@ -19228,7 +19228,7 @@
           <p:cNvPr id="15" name="">
             <a:extLst xmlns:a="http://schemas.openxmlformats.org/drawingml/2006/main">
               <a:ext uri="{FF2B5EF4-FFF2-40B4-BE49-F238E27FC236}">
-                <a16:creationId xmlns:a16="http://schemas.microsoft.com/office/drawing/2014/main" id="{BB6B185A-E1F0-4103-821E-716B289F5340}"/>
+                <a16:creationId xmlns:a16="http://schemas.microsoft.com/office/drawing/2014/main" id="{CF8069EF-52D4-400E-B456-029F7E671F8B}"/>
               </a:ext>
             </a:extLst>
           </p:cNvPr>
@@ -19260,7 +19260,7 @@
           <p:cNvPr id="16" name="">
             <a:extLst xmlns:a="http://schemas.openxmlformats.org/drawingml/2006/main">
               <a:ext uri="{FF2B5EF4-FFF2-40B4-BE49-F238E27FC236}">
-                <a16:creationId xmlns:a16="http://schemas.microsoft.com/office/drawing/2014/main" id="{B90FC067-2337-4035-8D71-C7BF90A267C0}"/>
+                <a16:creationId xmlns:a16="http://schemas.microsoft.com/office/drawing/2014/main" id="{87D5AF0F-04C7-41C7-A6E2-724B49A8AB84}"/>
               </a:ext>
             </a:extLst>
           </p:cNvPr>
@@ -19416,7 +19416,7 @@
           <p:cNvPr id="17" name="">
             <a:extLst xmlns:a="http://schemas.openxmlformats.org/drawingml/2006/main">
               <a:ext uri="{FF2B5EF4-FFF2-40B4-BE49-F238E27FC236}">
-                <a16:creationId xmlns:a16="http://schemas.microsoft.com/office/drawing/2014/main" id="{96AD4C75-925A-48DD-B046-B94FAC4F9A83}"/>
+                <a16:creationId xmlns:a16="http://schemas.microsoft.com/office/drawing/2014/main" id="{EE763DFE-6AB5-4D50-A895-95D473E35975}"/>
               </a:ext>
             </a:extLst>
           </p:cNvPr>
@@ -19562,7 +19562,7 @@
                 <a:ea typeface="Arial"/>
                 <a:cs typeface="Arial"/>
               </a:rPr>
-              <a:t>Referencia USD/PEN y fuente</a:t>
+              <a:t>Referencia USD/PEN</a:t>
             </a:r>
           </a:p>
         </p:txBody>
@@ -19572,7 +19572,7 @@
           <p:cNvPr id="18" name="">
             <a:extLst xmlns:a="http://schemas.openxmlformats.org/drawingml/2006/main">
               <a:ext uri="{FF2B5EF4-FFF2-40B4-BE49-F238E27FC236}">
-                <a16:creationId xmlns:a16="http://schemas.microsoft.com/office/drawing/2014/main" id="{15DF8393-D397-4A1E-9E70-47FF554DD5E4}"/>
+                <a16:creationId xmlns:a16="http://schemas.microsoft.com/office/drawing/2014/main" id="{AF2D7A0E-0B0D-4246-96C0-E935352A1689}"/>
               </a:ext>
             </a:extLst>
           </p:cNvPr>
@@ -19726,7 +19726,7 @@
     </p:spTree>
     <p:extLst>
       <p:ext uri="{BB962C8B-B14F-4D97-AF65-F5344CB8AC3E}">
-        <p14:creationId xmlns:p14="http://schemas.microsoft.com/office/powerpoint/2010/main" val="669511650"/>
+        <p14:creationId xmlns:p14="http://schemas.microsoft.com/office/powerpoint/2010/main" val="434768656"/>
       </p:ext>
     </p:extLst>
   </p:cSld>
@@ -19757,7 +19757,7 @@
           <p:cNvPr id="6" name="">
             <a:extLst xmlns:a="http://schemas.openxmlformats.org/drawingml/2006/main">
               <a:ext uri="{FF2B5EF4-FFF2-40B4-BE49-F238E27FC236}">
-                <a16:creationId xmlns:a16="http://schemas.microsoft.com/office/drawing/2014/main" id="{218CD6F5-BBEF-473C-AF80-F9E781919EB7}"/>
+                <a16:creationId xmlns:a16="http://schemas.microsoft.com/office/drawing/2014/main" id="{DEC1D440-57CD-4D0D-86C8-39C995C16DCF}"/>
               </a:ext>
             </a:extLst>
           </p:cNvPr>
@@ -19913,7 +19913,7 @@
           <p:cNvPr id="2" name="">
             <a:extLst xmlns:a="http://schemas.openxmlformats.org/drawingml/2006/main">
               <a:ext uri="{FF2B5EF4-FFF2-40B4-BE49-F238E27FC236}">
-                <a16:creationId xmlns:a16="http://schemas.microsoft.com/office/drawing/2014/main" id="{64741599-6764-457F-813C-D931CB41F33A}"/>
+                <a16:creationId xmlns:a16="http://schemas.microsoft.com/office/drawing/2014/main" id="{44151BF7-8BF1-4012-AE67-D2519160FF5B}"/>
               </a:ext>
             </a:extLst>
           </p:cNvPr>
@@ -20069,7 +20069,7 @@
           <p:cNvPr id="3" name="">
             <a:extLst xmlns:a="http://schemas.openxmlformats.org/drawingml/2006/main">
               <a:ext uri="{FF2B5EF4-FFF2-40B4-BE49-F238E27FC236}">
-                <a16:creationId xmlns:a16="http://schemas.microsoft.com/office/drawing/2014/main" id="{4400BF76-DAF2-49A7-93E7-DBB2F8433316}"/>
+                <a16:creationId xmlns:a16="http://schemas.microsoft.com/office/drawing/2014/main" id="{B33893DC-D27B-4345-AE37-5E0F4146529E}"/>
               </a:ext>
             </a:extLst>
           </p:cNvPr>
@@ -20079,7 +20079,7 @@
           <p:nvPr/>
         </p:nvPicPr>
         <p:blipFill>
-          <a:blip xmlns:r="http://schemas.openxmlformats.org/officeDocument/2006/relationships" xmlns:a="http://schemas.openxmlformats.org/drawingml/2006/main" r:embed="Rc5d2068e4d6a4e98"/>
+          <a:blip xmlns:r="http://schemas.openxmlformats.org/officeDocument/2006/relationships" xmlns:a="http://schemas.openxmlformats.org/drawingml/2006/main" r:embed="R78216013487b49a4"/>
           <a:stretch xmlns:a="http://schemas.openxmlformats.org/drawingml/2006/main"/>
         </p:blipFill>
         <p:spPr>
@@ -20097,7 +20097,7 @@
           <p:cNvPr id="4" name="">
             <a:extLst xmlns:a="http://schemas.openxmlformats.org/drawingml/2006/main">
               <a:ext uri="{FF2B5EF4-FFF2-40B4-BE49-F238E27FC236}">
-                <a16:creationId xmlns:a16="http://schemas.microsoft.com/office/drawing/2014/main" id="{814DB470-A43B-4465-93FF-3C1124122B32}"/>
+                <a16:creationId xmlns:a16="http://schemas.microsoft.com/office/drawing/2014/main" id="{A5028869-C19A-434F-8AEF-882A666A7AF4}"/>
               </a:ext>
             </a:extLst>
           </p:cNvPr>
@@ -20281,7 +20281,7 @@
           <p:cNvPr id="5" name="">
             <a:extLst xmlns:a="http://schemas.openxmlformats.org/drawingml/2006/main">
               <a:ext uri="{FF2B5EF4-FFF2-40B4-BE49-F238E27FC236}">
-                <a16:creationId xmlns:a16="http://schemas.microsoft.com/office/drawing/2014/main" id="{8DF5D4F6-E9AD-441D-8382-00B67489617F}"/>
+                <a16:creationId xmlns:a16="http://schemas.microsoft.com/office/drawing/2014/main" id="{022C113A-2733-4A02-B971-ABDB82405F3A}"/>
               </a:ext>
             </a:extLst>
           </p:cNvPr>
@@ -20435,7 +20435,7 @@
     </p:spTree>
     <p:extLst>
       <p:ext uri="{BB962C8B-B14F-4D97-AF65-F5344CB8AC3E}">
-        <p14:creationId xmlns:p14="http://schemas.microsoft.com/office/powerpoint/2010/main" val="1225068423"/>
+        <p14:creationId xmlns:p14="http://schemas.microsoft.com/office/powerpoint/2010/main" val="1434917705"/>
       </p:ext>
     </p:extLst>
   </p:cSld>
@@ -20466,7 +20466,7 @@
           <p:cNvPr id="7" name="">
             <a:extLst xmlns:a="http://schemas.openxmlformats.org/drawingml/2006/main">
               <a:ext uri="{FF2B5EF4-FFF2-40B4-BE49-F238E27FC236}">
-                <a16:creationId xmlns:a16="http://schemas.microsoft.com/office/drawing/2014/main" id="{C13BF0D6-45B3-45B8-83EF-FD1DF64ED10D}"/>
+                <a16:creationId xmlns:a16="http://schemas.microsoft.com/office/drawing/2014/main" id="{03312C0C-740C-46B5-8648-BF6B4D2FF73E}"/>
               </a:ext>
             </a:extLst>
           </p:cNvPr>
@@ -20622,7 +20622,7 @@
           <p:cNvPr id="2" name="">
             <a:extLst xmlns:a="http://schemas.openxmlformats.org/drawingml/2006/main">
               <a:ext uri="{FF2B5EF4-FFF2-40B4-BE49-F238E27FC236}">
-                <a16:creationId xmlns:a16="http://schemas.microsoft.com/office/drawing/2014/main" id="{18893379-9D00-4C2A-9D54-171474A3A6A7}"/>
+                <a16:creationId xmlns:a16="http://schemas.microsoft.com/office/drawing/2014/main" id="{DC6B09C0-B5CD-4751-822D-8A3BB02CAF1A}"/>
               </a:ext>
             </a:extLst>
           </p:cNvPr>
@@ -20778,7 +20778,7 @@
           <p:cNvPr id="3" name="">
             <a:extLst xmlns:a="http://schemas.openxmlformats.org/drawingml/2006/main">
               <a:ext uri="{FF2B5EF4-FFF2-40B4-BE49-F238E27FC236}">
-                <a16:creationId xmlns:a16="http://schemas.microsoft.com/office/drawing/2014/main" id="{BB74CDED-0F59-4529-A65A-30843296FB13}"/>
+                <a16:creationId xmlns:a16="http://schemas.microsoft.com/office/drawing/2014/main" id="{639B8EE5-B187-41EF-AF7F-0C9D5CA52CA4}"/>
               </a:ext>
             </a:extLst>
           </p:cNvPr>
@@ -21049,7 +21049,7 @@
           <p:cNvPr id="4" name="">
             <a:extLst xmlns:a="http://schemas.openxmlformats.org/drawingml/2006/main">
               <a:ext uri="{FF2B5EF4-FFF2-40B4-BE49-F238E27FC236}">
-                <a16:creationId xmlns:a16="http://schemas.microsoft.com/office/drawing/2014/main" id="{57EC1ED0-DB94-449E-8ACB-1B8CB60AB3C6}"/>
+                <a16:creationId xmlns:a16="http://schemas.microsoft.com/office/drawing/2014/main" id="{A4F2D316-5B1F-40DB-A561-E8749C93E5BB}"/>
               </a:ext>
             </a:extLst>
           </p:cNvPr>
@@ -21205,7 +21205,7 @@
           <p:cNvPr id="5" name="">
             <a:extLst xmlns:a="http://schemas.openxmlformats.org/drawingml/2006/main">
               <a:ext uri="{FF2B5EF4-FFF2-40B4-BE49-F238E27FC236}">
-                <a16:creationId xmlns:a16="http://schemas.microsoft.com/office/drawing/2014/main" id="{E3AE7BB9-3330-4407-9791-E0A64FBF69F8}"/>
+                <a16:creationId xmlns:a16="http://schemas.microsoft.com/office/drawing/2014/main" id="{A68A2A1C-72C7-45B2-AC99-91F13269F658}"/>
               </a:ext>
             </a:extLst>
           </p:cNvPr>
@@ -21215,7 +21215,7 @@
           <p:nvPr/>
         </p:nvPicPr>
         <p:blipFill>
-          <a:blip xmlns:r="http://schemas.openxmlformats.org/officeDocument/2006/relationships" xmlns:a="http://schemas.openxmlformats.org/drawingml/2006/main" r:embed="Rc29ff1f686ea451e"/>
+          <a:blip xmlns:r="http://schemas.openxmlformats.org/officeDocument/2006/relationships" xmlns:a="http://schemas.openxmlformats.org/drawingml/2006/main" r:embed="Re5cff53bd81a4818"/>
           <a:stretch xmlns:a="http://schemas.openxmlformats.org/drawingml/2006/main"/>
         </p:blipFill>
         <p:spPr>
@@ -21233,7 +21233,7 @@
           <p:cNvPr id="6" name="">
             <a:extLst xmlns:a="http://schemas.openxmlformats.org/drawingml/2006/main">
               <a:ext uri="{FF2B5EF4-FFF2-40B4-BE49-F238E27FC236}">
-                <a16:creationId xmlns:a16="http://schemas.microsoft.com/office/drawing/2014/main" id="{D3C1E46F-4864-41EB-9A41-75DFFD273198}"/>
+                <a16:creationId xmlns:a16="http://schemas.microsoft.com/office/drawing/2014/main" id="{71C0A325-8894-40AB-8B48-11B4253438A0}"/>
               </a:ext>
             </a:extLst>
           </p:cNvPr>
@@ -21387,7 +21387,7 @@
     </p:spTree>
     <p:extLst>
       <p:ext uri="{BB962C8B-B14F-4D97-AF65-F5344CB8AC3E}">
-        <p14:creationId xmlns:p14="http://schemas.microsoft.com/office/powerpoint/2010/main" val="1718257424"/>
+        <p14:creationId xmlns:p14="http://schemas.microsoft.com/office/powerpoint/2010/main" val="1770396491"/>
       </p:ext>
     </p:extLst>
   </p:cSld>
@@ -21418,7 +21418,7 @@
           <p:cNvPr id="6" name="">
             <a:extLst xmlns:a="http://schemas.openxmlformats.org/drawingml/2006/main">
               <a:ext uri="{FF2B5EF4-FFF2-40B4-BE49-F238E27FC236}">
-                <a16:creationId xmlns:a16="http://schemas.microsoft.com/office/drawing/2014/main" id="{3AE56E37-615F-46CD-9321-928B51AC466E}"/>
+                <a16:creationId xmlns:a16="http://schemas.microsoft.com/office/drawing/2014/main" id="{9A15EFE1-6273-4859-A11D-11269136A67D}"/>
               </a:ext>
             </a:extLst>
           </p:cNvPr>
@@ -21574,7 +21574,7 @@
           <p:cNvPr id="2" name="">
             <a:extLst xmlns:a="http://schemas.openxmlformats.org/drawingml/2006/main">
               <a:ext uri="{FF2B5EF4-FFF2-40B4-BE49-F238E27FC236}">
-                <a16:creationId xmlns:a16="http://schemas.microsoft.com/office/drawing/2014/main" id="{9CE8AAC7-250E-414D-BC48-B133BBFC0A44}"/>
+                <a16:creationId xmlns:a16="http://schemas.microsoft.com/office/drawing/2014/main" id="{3C990C38-4698-42A3-B90B-468A2874D1F4}"/>
               </a:ext>
             </a:extLst>
           </p:cNvPr>
@@ -21730,7 +21730,7 @@
           <p:cNvPr id="3" name="">
             <a:extLst xmlns:a="http://schemas.openxmlformats.org/drawingml/2006/main">
               <a:ext uri="{FF2B5EF4-FFF2-40B4-BE49-F238E27FC236}">
-                <a16:creationId xmlns:a16="http://schemas.microsoft.com/office/drawing/2014/main" id="{7F5E528A-9A4D-4BF4-B8AB-14DBCFD86BD2}"/>
+                <a16:creationId xmlns:a16="http://schemas.microsoft.com/office/drawing/2014/main" id="{57B319F2-ADB2-4251-9DE5-9B241137D81B}"/>
               </a:ext>
             </a:extLst>
           </p:cNvPr>
@@ -21740,7 +21740,7 @@
           <p:nvPr/>
         </p:nvPicPr>
         <p:blipFill>
-          <a:blip xmlns:r="http://schemas.openxmlformats.org/officeDocument/2006/relationships" xmlns:a="http://schemas.openxmlformats.org/drawingml/2006/main" r:embed="Rfc270600a3274474"/>
+          <a:blip xmlns:r="http://schemas.openxmlformats.org/officeDocument/2006/relationships" xmlns:a="http://schemas.openxmlformats.org/drawingml/2006/main" r:embed="R8780d41db6db4f9f"/>
           <a:stretch xmlns:a="http://schemas.openxmlformats.org/drawingml/2006/main"/>
         </p:blipFill>
         <p:spPr>
@@ -21758,7 +21758,7 @@
           <p:cNvPr id="4" name="">
             <a:extLst xmlns:a="http://schemas.openxmlformats.org/drawingml/2006/main">
               <a:ext uri="{FF2B5EF4-FFF2-40B4-BE49-F238E27FC236}">
-                <a16:creationId xmlns:a16="http://schemas.microsoft.com/office/drawing/2014/main" id="{86A4334B-0C92-408D-A3DB-36C100F6CF08}"/>
+                <a16:creationId xmlns:a16="http://schemas.microsoft.com/office/drawing/2014/main" id="{670CFD59-2D3A-49A6-A43E-6CE0802FFD56}"/>
               </a:ext>
             </a:extLst>
           </p:cNvPr>
@@ -21970,7 +21970,7 @@
           <p:cNvPr id="5" name="">
             <a:extLst xmlns:a="http://schemas.openxmlformats.org/drawingml/2006/main">
               <a:ext uri="{FF2B5EF4-FFF2-40B4-BE49-F238E27FC236}">
-                <a16:creationId xmlns:a16="http://schemas.microsoft.com/office/drawing/2014/main" id="{F55FE593-BFBD-4020-9488-A34A21259AB6}"/>
+                <a16:creationId xmlns:a16="http://schemas.microsoft.com/office/drawing/2014/main" id="{1A189CA3-63B2-4791-A49F-153B11587504}"/>
               </a:ext>
             </a:extLst>
           </p:cNvPr>
@@ -22124,7 +22124,7 @@
     </p:spTree>
     <p:extLst>
       <p:ext uri="{BB962C8B-B14F-4D97-AF65-F5344CB8AC3E}">
-        <p14:creationId xmlns:p14="http://schemas.microsoft.com/office/powerpoint/2010/main" val="1301851333"/>
+        <p14:creationId xmlns:p14="http://schemas.microsoft.com/office/powerpoint/2010/main" val="37828732"/>
       </p:ext>
     </p:extLst>
   </p:cSld>

</xml_diff>